<commit_message>
Mise à jour 3
</commit_message>
<xml_diff>
--- a/E-SCHOOL (1).pptx
+++ b/E-SCHOOL (1).pptx
@@ -7119,7 +7119,7 @@
         </p:nvSpPr>
         <p:spPr>
           <a:xfrm>
-            <a:off x="1055450" y="1960721"/>
+            <a:off x="1075770" y="1859121"/>
             <a:ext cx="3881011" cy="1951911"/>
           </a:xfrm>
           <a:prstGeom prst="roundRect">
@@ -7739,7 +7739,7 @@
         </p:nvSpPr>
         <p:spPr>
           <a:xfrm>
-            <a:off x="1263460" y="4187666"/>
+            <a:off x="1124145" y="4074675"/>
             <a:ext cx="1952387" cy="225981"/>
           </a:xfrm>
           <a:prstGeom prst="rect">
@@ -7781,7 +7781,7 @@
         </p:nvSpPr>
         <p:spPr>
           <a:xfrm>
-            <a:off x="2323148" y="4449723"/>
+            <a:off x="1798759" y="4475917"/>
             <a:ext cx="7380208" cy="452080"/>
           </a:xfrm>
           <a:prstGeom prst="rect">
@@ -7823,8 +7823,8 @@
         </p:nvSpPr>
         <p:spPr>
           <a:xfrm>
-            <a:off x="2323148" y="4927997"/>
-            <a:ext cx="9984105" cy="473869"/>
+            <a:off x="1577212" y="4927997"/>
+            <a:ext cx="10730041" cy="685794"/>
           </a:xfrm>
           <a:prstGeom prst="rect">
             <a:avLst/>
@@ -8819,7 +8819,7 @@
         <p:spPr>
           <a:xfrm>
             <a:off x="674489" y="4702850"/>
-            <a:ext cx="3990023" cy="361355"/>
+            <a:ext cx="5665351" cy="397470"/>
           </a:xfrm>
           <a:prstGeom prst="rect">
             <a:avLst/>
@@ -8838,28 +8838,13 @@
               <a:buNone/>
             </a:pPr>
             <a:r>
-              <a:rPr lang="en-US" sz="3200" dirty="0">
-                <a:solidFill>
-                  <a:srgbClr val="FFFFFF"/>
-                </a:solidFill>
-                <a:latin typeface="Roboto Mono Medium" pitchFamily="34" charset="0"/>
-                <a:ea typeface="Roboto Mono Medium" pitchFamily="34" charset="-122"/>
-                <a:cs typeface="Roboto Mono Medium" pitchFamily="34" charset="-120"/>
-              </a:rPr>
-              <a:t>Hypothèse</a:t>
-            </a:r>
-            <a:r>
-              <a:rPr lang="en-US" sz="2800" dirty="0">
-                <a:solidFill>
-                  <a:srgbClr val="FFFFFF"/>
-                </a:solidFill>
-                <a:latin typeface="Roboto Mono Medium" pitchFamily="34" charset="0"/>
-                <a:ea typeface="Roboto Mono Medium" pitchFamily="34" charset="-122"/>
-                <a:cs typeface="Roboto Mono Medium" pitchFamily="34" charset="-120"/>
-              </a:rPr>
-              <a:t> conservatrice</a:t>
-            </a:r>
-            <a:endParaRPr lang="en-US" sz="2800" dirty="0"/>
+              <a:rPr lang="en-US" sz="2800" dirty="0" err="1"/>
+              <a:t>Abonnnement</a:t>
+            </a:r>
+            <a:r>
+              <a:rPr lang="en-US" sz="2800" dirty="0"/>
+              <a:t>  : 800-1000 $</a:t>
+            </a:r>
           </a:p>
         </p:txBody>
       </p:sp>
@@ -8897,15 +8882,19 @@
                 <a:ea typeface="Roboto" pitchFamily="34" charset="-122"/>
                 <a:cs typeface="Roboto" pitchFamily="34" charset="-120"/>
               </a:rPr>
-              <a:t>50 écoles = 72 000 $ / an</a:t>
-            </a:r>
-            <a:endParaRPr lang="en-US" sz="2000" dirty="0"/>
-          </a:p>
-          <a:p>
-            <a:pPr marL="342900" indent="-342900" algn="l">
-              <a:buSzPct val="100000"/>
-              <a:buChar char="•"/>
-            </a:pPr>
+              <a:t>Frais </a:t>
+            </a:r>
+            <a:r>
+              <a:rPr lang="en-US" sz="2000" dirty="0" err="1">
+                <a:solidFill>
+                  <a:srgbClr val="E5E0DF"/>
+                </a:solidFill>
+                <a:latin typeface="Roboto" pitchFamily="34" charset="0"/>
+                <a:ea typeface="Roboto" pitchFamily="34" charset="-122"/>
+                <a:cs typeface="Roboto" pitchFamily="34" charset="-120"/>
+              </a:rPr>
+              <a:t>mensualité</a:t>
+            </a:r>
             <a:r>
               <a:rPr lang="en-US" sz="2000" dirty="0">
                 <a:solidFill>
@@ -8915,109 +8904,7 @@
                 <a:ea typeface="Roboto" pitchFamily="34" charset="-122"/>
                 <a:cs typeface="Roboto" pitchFamily="34" charset="-120"/>
               </a:rPr>
-              <a:t>100 écoles = 144 000 $ / an</a:t>
-            </a:r>
-            <a:endParaRPr lang="en-US" sz="2000" dirty="0"/>
-          </a:p>
-          <a:p>
-            <a:pPr marL="342900" indent="-342900" algn="l">
-              <a:buSzPct val="100000"/>
-              <a:buChar char="•"/>
-            </a:pPr>
-            <a:r>
-              <a:rPr lang="en-US" sz="2000" dirty="0">
-                <a:solidFill>
-                  <a:srgbClr val="E5E0DF"/>
-                </a:solidFill>
-                <a:latin typeface="Roboto" pitchFamily="34" charset="0"/>
-                <a:ea typeface="Roboto" pitchFamily="34" charset="-122"/>
-                <a:cs typeface="Roboto" pitchFamily="34" charset="-120"/>
-              </a:rPr>
-              <a:t>200 écoles = 288 000 $ / an</a:t>
-            </a:r>
-            <a:endParaRPr lang="en-US" sz="2000" dirty="0"/>
-          </a:p>
-        </p:txBody>
-      </p:sp>
-      <p:sp>
-        <p:nvSpPr>
-          <p:cNvPr id="12" name="Text 10"/>
-          <p:cNvSpPr/>
-          <p:nvPr/>
-        </p:nvSpPr>
-        <p:spPr>
-          <a:xfrm>
-            <a:off x="674489" y="6525458"/>
-            <a:ext cx="3643074" cy="361355"/>
-          </a:xfrm>
-          <a:prstGeom prst="rect">
-            <a:avLst/>
-          </a:prstGeom>
-          <a:noFill/>
-          <a:ln/>
-        </p:spPr>
-        <p:txBody>
-          <a:bodyPr wrap="none" lIns="0" tIns="0" rIns="0" bIns="0" rtlCol="0" anchor="t"/>
-          <a:lstStyle/>
-          <a:p>
-            <a:pPr marL="0" indent="0" algn="l">
-              <a:lnSpc>
-                <a:spcPts val="2800"/>
-              </a:lnSpc>
-              <a:buNone/>
-            </a:pPr>
-            <a:r>
-              <a:rPr lang="en-US" sz="2800" dirty="0">
-                <a:solidFill>
-                  <a:srgbClr val="FFFFFF"/>
-                </a:solidFill>
-                <a:latin typeface="Roboto Mono Medium" pitchFamily="34" charset="0"/>
-                <a:ea typeface="Roboto Mono Medium" pitchFamily="34" charset="-122"/>
-                <a:cs typeface="Roboto Mono Medium" pitchFamily="34" charset="-120"/>
-              </a:rPr>
-              <a:t>Commissions paiements</a:t>
-            </a:r>
-            <a:endParaRPr lang="en-US" sz="2800" dirty="0"/>
-          </a:p>
-        </p:txBody>
-      </p:sp>
-      <p:sp>
-        <p:nvSpPr>
-          <p:cNvPr id="13" name="Text 11"/>
-          <p:cNvSpPr/>
-          <p:nvPr/>
-        </p:nvSpPr>
-        <p:spPr>
-          <a:xfrm>
-            <a:off x="1183341" y="7132439"/>
-            <a:ext cx="12772570" cy="285155"/>
-          </a:xfrm>
-          <a:prstGeom prst="rect">
-            <a:avLst/>
-          </a:prstGeom>
-          <a:noFill/>
-          <a:ln/>
-        </p:spPr>
-        <p:txBody>
-          <a:bodyPr wrap="none" lIns="0" tIns="0" rIns="0" bIns="0" rtlCol="0" anchor="t"/>
-          <a:lstStyle/>
-          <a:p>
-            <a:pPr marL="0" indent="0" algn="l">
-              <a:lnSpc>
-                <a:spcPts val="2200"/>
-              </a:lnSpc>
-              <a:buNone/>
-            </a:pPr>
-            <a:r>
-              <a:rPr lang="en-US" sz="2000" dirty="0">
-                <a:solidFill>
-                  <a:srgbClr val="E5E0DF"/>
-                </a:solidFill>
-                <a:latin typeface="Roboto" pitchFamily="34" charset="0"/>
-                <a:ea typeface="Roboto" pitchFamily="34" charset="-122"/>
-                <a:cs typeface="Roboto" pitchFamily="34" charset="-120"/>
-              </a:rPr>
-              <a:t>Projection à 100 écoles : ≈ 200 000 – 250 000 $ / an</a:t>
+              <a:t> : 200 – 300 $</a:t>
             </a:r>
             <a:endParaRPr lang="en-US" sz="2000" dirty="0"/>
           </a:p>

</xml_diff>